<commit_message>
updated VR controller mappings
</commit_message>
<xml_diff>
--- a/sunriseRobot/app_SunriseRobot/info/vr_controller_map_en.pptx
+++ b/sunriseRobot/app_SunriseRobot/info/vr_controller_map_en.pptx
@@ -4491,6 +4491,146 @@
               <a:rPr lang="en-US" noProof="0" dirty="0"/>
               <a:t> is Start</a:t>
             </a:r>
+          </a:p>
+        </p:txBody>
+      </p:sp>
+      <p:sp>
+        <p:nvSpPr>
+          <p:cNvPr id="2" name="Rectangle 1">
+            <a:extLst>
+              <a:ext uri="{FF2B5EF4-FFF2-40B4-BE49-F238E27FC236}">
+                <a16:creationId xmlns:a16="http://schemas.microsoft.com/office/drawing/2014/main" id="{A7B29C44-256F-0BD0-2B8F-AF209C3CB6A3}"/>
+              </a:ext>
+            </a:extLst>
+          </p:cNvPr>
+          <p:cNvSpPr/>
+          <p:nvPr/>
+        </p:nvSpPr>
+        <p:spPr>
+          <a:xfrm>
+            <a:off x="3671196" y="3920412"/>
+            <a:ext cx="1242433" cy="1077831"/>
+          </a:xfrm>
+          <a:prstGeom prst="rect">
+            <a:avLst/>
+          </a:prstGeom>
+          <a:noFill/>
+          <a:ln w="38100">
+            <a:solidFill>
+              <a:srgbClr val="FF0000"/>
+            </a:solidFill>
+          </a:ln>
+        </p:spPr>
+        <p:style>
+          <a:lnRef idx="2">
+            <a:schemeClr val="accent1">
+              <a:shade val="15000"/>
+            </a:schemeClr>
+          </a:lnRef>
+          <a:fillRef idx="1">
+            <a:schemeClr val="accent1"/>
+          </a:fillRef>
+          <a:effectRef idx="0">
+            <a:schemeClr val="accent1"/>
+          </a:effectRef>
+          <a:fontRef idx="minor">
+            <a:schemeClr val="lt1"/>
+          </a:fontRef>
+        </p:style>
+        <p:txBody>
+          <a:bodyPr rtlCol="0" anchor="ctr"/>
+          <a:lstStyle/>
+          <a:p>
+            <a:pPr algn="ctr"/>
+            <a:endParaRPr lang="en-US"/>
+          </a:p>
+        </p:txBody>
+      </p:sp>
+      <p:cxnSp>
+        <p:nvCxnSpPr>
+          <p:cNvPr id="3" name="Connector: Elbow 2">
+            <a:extLst>
+              <a:ext uri="{FF2B5EF4-FFF2-40B4-BE49-F238E27FC236}">
+                <a16:creationId xmlns:a16="http://schemas.microsoft.com/office/drawing/2014/main" id="{E753E20C-E36D-6F59-3416-CEFE630D2E8E}"/>
+              </a:ext>
+            </a:extLst>
+          </p:cNvPr>
+          <p:cNvCxnSpPr>
+            <a:cxnSpLocks/>
+            <a:stCxn id="7" idx="3"/>
+            <a:endCxn id="2" idx="1"/>
+          </p:cNvCxnSpPr>
+          <p:nvPr/>
+        </p:nvCxnSpPr>
+        <p:spPr>
+          <a:xfrm flipV="1">
+            <a:off x="2033547" y="4459328"/>
+            <a:ext cx="1637649" cy="1662839"/>
+          </a:xfrm>
+          <a:prstGeom prst="bentConnector3">
+            <a:avLst>
+              <a:gd name="adj1" fmla="val 50000"/>
+            </a:avLst>
+          </a:prstGeom>
+          <a:ln w="38100">
+            <a:solidFill>
+              <a:srgbClr val="FF0000"/>
+            </a:solidFill>
+          </a:ln>
+        </p:spPr>
+        <p:style>
+          <a:lnRef idx="2">
+            <a:schemeClr val="accent1"/>
+          </a:lnRef>
+          <a:fillRef idx="0">
+            <a:schemeClr val="accent1"/>
+          </a:fillRef>
+          <a:effectRef idx="1">
+            <a:schemeClr val="accent1"/>
+          </a:effectRef>
+          <a:fontRef idx="minor">
+            <a:schemeClr val="tx1"/>
+          </a:fontRef>
+        </p:style>
+      </p:cxnSp>
+      <p:sp>
+        <p:nvSpPr>
+          <p:cNvPr id="7" name="TextBox 6">
+            <a:extLst>
+              <a:ext uri="{FF2B5EF4-FFF2-40B4-BE49-F238E27FC236}">
+                <a16:creationId xmlns:a16="http://schemas.microsoft.com/office/drawing/2014/main" id="{AE4D12E5-B8A5-AE15-0784-CA1D41403AA9}"/>
+              </a:ext>
+            </a:extLst>
+          </p:cNvPr>
+          <p:cNvSpPr txBox="1"/>
+          <p:nvPr/>
+        </p:nvSpPr>
+        <p:spPr>
+          <a:xfrm>
+            <a:off x="533881" y="5660502"/>
+            <a:ext cx="1499666" cy="923330"/>
+          </a:xfrm>
+          <a:prstGeom prst="rect">
+            <a:avLst/>
+          </a:prstGeom>
+          <a:noFill/>
+          <a:ln w="28575">
+            <a:solidFill>
+              <a:srgbClr val="FF0000"/>
+            </a:solidFill>
+          </a:ln>
+        </p:spPr>
+        <p:txBody>
+          <a:bodyPr wrap="square" rtlCol="0">
+            <a:spAutoFit/>
+          </a:bodyPr>
+          <a:lstStyle/>
+          <a:p>
+            <a:r>
+              <a:rPr lang="en-US" b="1" noProof="0" dirty="0"/>
+              <a:t>Not mapped in the VR controllers!</a:t>
+            </a:r>
+            <a:endParaRPr lang="en-US" sz="1600" noProof="0" dirty="0"/>
           </a:p>
         </p:txBody>
       </p:sp>

</xml_diff>

<commit_message>
updated vr controller buttons and mapping
</commit_message>
<xml_diff>
--- a/sunriseRobot/app_SunriseRobot/info/vr_controller_map_en.pptx
+++ b/sunriseRobot/app_SunriseRobot/info/vr_controller_map_en.pptx
@@ -259,7 +259,7 @@
           <a:p>
             <a:fld id="{60B78028-44F6-416E-B0AB-FAA3EA91683A}" type="datetimeFigureOut">
               <a:rPr lang="en-US" smtClean="0"/>
-              <a:t>4/6/2026</a:t>
+              <a:t>4/15/2026</a:t>
             </a:fld>
             <a:endParaRPr lang="en-US"/>
           </a:p>
@@ -457,7 +457,7 @@
           <a:p>
             <a:fld id="{60B78028-44F6-416E-B0AB-FAA3EA91683A}" type="datetimeFigureOut">
               <a:rPr lang="en-US" smtClean="0"/>
-              <a:t>4/6/2026</a:t>
+              <a:t>4/15/2026</a:t>
             </a:fld>
             <a:endParaRPr lang="en-US"/>
           </a:p>
@@ -665,7 +665,7 @@
           <a:p>
             <a:fld id="{60B78028-44F6-416E-B0AB-FAA3EA91683A}" type="datetimeFigureOut">
               <a:rPr lang="en-US" smtClean="0"/>
-              <a:t>4/6/2026</a:t>
+              <a:t>4/15/2026</a:t>
             </a:fld>
             <a:endParaRPr lang="en-US"/>
           </a:p>
@@ -863,7 +863,7 @@
           <a:p>
             <a:fld id="{60B78028-44F6-416E-B0AB-FAA3EA91683A}" type="datetimeFigureOut">
               <a:rPr lang="en-US" smtClean="0"/>
-              <a:t>4/6/2026</a:t>
+              <a:t>4/15/2026</a:t>
             </a:fld>
             <a:endParaRPr lang="en-US"/>
           </a:p>
@@ -1138,7 +1138,7 @@
           <a:p>
             <a:fld id="{60B78028-44F6-416E-B0AB-FAA3EA91683A}" type="datetimeFigureOut">
               <a:rPr lang="en-US" smtClean="0"/>
-              <a:t>4/6/2026</a:t>
+              <a:t>4/15/2026</a:t>
             </a:fld>
             <a:endParaRPr lang="en-US"/>
           </a:p>
@@ -1403,7 +1403,7 @@
           <a:p>
             <a:fld id="{60B78028-44F6-416E-B0AB-FAA3EA91683A}" type="datetimeFigureOut">
               <a:rPr lang="en-US" smtClean="0"/>
-              <a:t>4/6/2026</a:t>
+              <a:t>4/15/2026</a:t>
             </a:fld>
             <a:endParaRPr lang="en-US"/>
           </a:p>
@@ -1815,7 +1815,7 @@
           <a:p>
             <a:fld id="{60B78028-44F6-416E-B0AB-FAA3EA91683A}" type="datetimeFigureOut">
               <a:rPr lang="en-US" smtClean="0"/>
-              <a:t>4/6/2026</a:t>
+              <a:t>4/15/2026</a:t>
             </a:fld>
             <a:endParaRPr lang="en-US"/>
           </a:p>
@@ -1956,7 +1956,7 @@
           <a:p>
             <a:fld id="{60B78028-44F6-416E-B0AB-FAA3EA91683A}" type="datetimeFigureOut">
               <a:rPr lang="en-US" smtClean="0"/>
-              <a:t>4/6/2026</a:t>
+              <a:t>4/15/2026</a:t>
             </a:fld>
             <a:endParaRPr lang="en-US"/>
           </a:p>
@@ -2069,7 +2069,7 @@
           <a:p>
             <a:fld id="{60B78028-44F6-416E-B0AB-FAA3EA91683A}" type="datetimeFigureOut">
               <a:rPr lang="en-US" smtClean="0"/>
-              <a:t>4/6/2026</a:t>
+              <a:t>4/15/2026</a:t>
             </a:fld>
             <a:endParaRPr lang="en-US"/>
           </a:p>
@@ -2380,7 +2380,7 @@
           <a:p>
             <a:fld id="{60B78028-44F6-416E-B0AB-FAA3EA91683A}" type="datetimeFigureOut">
               <a:rPr lang="en-US" smtClean="0"/>
-              <a:t>4/6/2026</a:t>
+              <a:t>4/15/2026</a:t>
             </a:fld>
             <a:endParaRPr lang="en-US"/>
           </a:p>
@@ -2668,7 +2668,7 @@
           <a:p>
             <a:fld id="{60B78028-44F6-416E-B0AB-FAA3EA91683A}" type="datetimeFigureOut">
               <a:rPr lang="en-US" smtClean="0"/>
-              <a:t>4/6/2026</a:t>
+              <a:t>4/15/2026</a:t>
             </a:fld>
             <a:endParaRPr lang="en-US"/>
           </a:p>
@@ -2909,7 +2909,7 @@
           <a:p>
             <a:fld id="{60B78028-44F6-416E-B0AB-FAA3EA91683A}" type="datetimeFigureOut">
               <a:rPr lang="en-US" smtClean="0"/>
-              <a:t>4/6/2026</a:t>
+              <a:t>4/15/2026</a:t>
             </a:fld>
             <a:endParaRPr lang="en-US"/>
           </a:p>
@@ -4400,102 +4400,6 @@
       </p:cxnSp>
       <p:sp>
         <p:nvSpPr>
-          <p:cNvPr id="1082" name="TextBox 1081">
-            <a:extLst>
-              <a:ext uri="{FF2B5EF4-FFF2-40B4-BE49-F238E27FC236}">
-                <a16:creationId xmlns:a16="http://schemas.microsoft.com/office/drawing/2014/main" id="{0869E331-1CFA-CA17-DED3-50C431B3C82B}"/>
-              </a:ext>
-            </a:extLst>
-          </p:cNvPr>
-          <p:cNvSpPr txBox="1"/>
-          <p:nvPr/>
-        </p:nvSpPr>
-        <p:spPr>
-          <a:xfrm>
-            <a:off x="3704533" y="795952"/>
-            <a:ext cx="1781593" cy="646331"/>
-          </a:xfrm>
-          <a:prstGeom prst="rect">
-            <a:avLst/>
-          </a:prstGeom>
-          <a:noFill/>
-          <a:ln w="28575">
-            <a:solidFill>
-              <a:srgbClr val="FFC000"/>
-            </a:solidFill>
-          </a:ln>
-        </p:spPr>
-        <p:txBody>
-          <a:bodyPr wrap="square" rtlCol="0">
-            <a:spAutoFit/>
-          </a:bodyPr>
-          <a:lstStyle/>
-          <a:p>
-            <a:r>
-              <a:rPr lang="en-US" noProof="0" dirty="0"/>
-              <a:t>Left Joystick </a:t>
-            </a:r>
-            <a:r>
-              <a:rPr lang="en-US" b="1" noProof="0" dirty="0"/>
-              <a:t>CLICK</a:t>
-            </a:r>
-            <a:r>
-              <a:rPr lang="en-US" noProof="0" dirty="0"/>
-              <a:t> is Select</a:t>
-            </a:r>
-          </a:p>
-        </p:txBody>
-      </p:sp>
-      <p:sp>
-        <p:nvSpPr>
-          <p:cNvPr id="1083" name="TextBox 1082">
-            <a:extLst>
-              <a:ext uri="{FF2B5EF4-FFF2-40B4-BE49-F238E27FC236}">
-                <a16:creationId xmlns:a16="http://schemas.microsoft.com/office/drawing/2014/main" id="{C8A56F52-85D4-E62D-25B8-3D9F9F2E8A4A}"/>
-              </a:ext>
-            </a:extLst>
-          </p:cNvPr>
-          <p:cNvSpPr txBox="1"/>
-          <p:nvPr/>
-        </p:nvSpPr>
-        <p:spPr>
-          <a:xfrm>
-            <a:off x="6811564" y="795952"/>
-            <a:ext cx="1667811" cy="646331"/>
-          </a:xfrm>
-          <a:prstGeom prst="rect">
-            <a:avLst/>
-          </a:prstGeom>
-          <a:noFill/>
-          <a:ln w="28575">
-            <a:solidFill>
-              <a:srgbClr val="FFC000"/>
-            </a:solidFill>
-          </a:ln>
-        </p:spPr>
-        <p:txBody>
-          <a:bodyPr wrap="square" rtlCol="0">
-            <a:spAutoFit/>
-          </a:bodyPr>
-          <a:lstStyle/>
-          <a:p>
-            <a:r>
-              <a:rPr lang="en-US" noProof="0" dirty="0"/>
-              <a:t>Right Joystick </a:t>
-            </a:r>
-            <a:r>
-              <a:rPr lang="en-US" b="1" dirty="0"/>
-              <a:t>CLICK</a:t>
-            </a:r>
-            <a:r>
-              <a:rPr lang="en-US" noProof="0" dirty="0"/>
-              <a:t> is Start</a:t>
-            </a:r>
-          </a:p>
-        </p:txBody>
-      </p:sp>
-      <p:sp>
-        <p:nvSpPr>
           <p:cNvPr id="2" name="Rectangle 1">
             <a:extLst>
               <a:ext uri="{FF2B5EF4-FFF2-40B4-BE49-F238E27FC236}">
@@ -4631,6 +4535,267 @@
               <a:t>Not mapped in the VR controllers!</a:t>
             </a:r>
             <a:endParaRPr lang="en-US" sz="1600" noProof="0" dirty="0"/>
+          </a:p>
+        </p:txBody>
+      </p:sp>
+      <p:sp>
+        <p:nvSpPr>
+          <p:cNvPr id="8" name="TextBox 7">
+            <a:extLst>
+              <a:ext uri="{FF2B5EF4-FFF2-40B4-BE49-F238E27FC236}">
+                <a16:creationId xmlns:a16="http://schemas.microsoft.com/office/drawing/2014/main" id="{C2E3B2CC-F630-1A5D-1D32-0B8DC7AD63BA}"/>
+              </a:ext>
+            </a:extLst>
+          </p:cNvPr>
+          <p:cNvSpPr txBox="1"/>
+          <p:nvPr/>
+        </p:nvSpPr>
+        <p:spPr>
+          <a:xfrm>
+            <a:off x="3537300" y="1076579"/>
+            <a:ext cx="945509" cy="369332"/>
+          </a:xfrm>
+          <a:prstGeom prst="rect">
+            <a:avLst/>
+          </a:prstGeom>
+          <a:noFill/>
+          <a:ln w="28575">
+            <a:solidFill>
+              <a:srgbClr val="FFC000"/>
+            </a:solidFill>
+          </a:ln>
+        </p:spPr>
+        <p:txBody>
+          <a:bodyPr wrap="square" rtlCol="0">
+            <a:spAutoFit/>
+          </a:bodyPr>
+          <a:lstStyle/>
+          <a:p>
+            <a:r>
+              <a:rPr lang="en-US" b="1" dirty="0"/>
+              <a:t>CLICK</a:t>
+            </a:r>
+            <a:endParaRPr lang="en-US" noProof="0" dirty="0"/>
+          </a:p>
+        </p:txBody>
+      </p:sp>
+      <p:sp>
+        <p:nvSpPr>
+          <p:cNvPr id="11" name="TextBox 10">
+            <a:extLst>
+              <a:ext uri="{FF2B5EF4-FFF2-40B4-BE49-F238E27FC236}">
+                <a16:creationId xmlns:a16="http://schemas.microsoft.com/office/drawing/2014/main" id="{339C41EE-5565-FD1A-1E29-89B2E67346BF}"/>
+              </a:ext>
+            </a:extLst>
+          </p:cNvPr>
+          <p:cNvSpPr txBox="1"/>
+          <p:nvPr/>
+        </p:nvSpPr>
+        <p:spPr>
+          <a:xfrm>
+            <a:off x="7673126" y="1076559"/>
+            <a:ext cx="945509" cy="369332"/>
+          </a:xfrm>
+          <a:prstGeom prst="rect">
+            <a:avLst/>
+          </a:prstGeom>
+          <a:noFill/>
+          <a:ln w="28575">
+            <a:solidFill>
+              <a:srgbClr val="FFC000"/>
+            </a:solidFill>
+          </a:ln>
+        </p:spPr>
+        <p:txBody>
+          <a:bodyPr wrap="square" rtlCol="0">
+            <a:spAutoFit/>
+          </a:bodyPr>
+          <a:lstStyle/>
+          <a:p>
+            <a:r>
+              <a:rPr lang="en-US" b="1" dirty="0"/>
+              <a:t>CLICK</a:t>
+            </a:r>
+            <a:endParaRPr lang="en-US" noProof="0" dirty="0"/>
+          </a:p>
+        </p:txBody>
+      </p:sp>
+      <p:sp>
+        <p:nvSpPr>
+          <p:cNvPr id="12" name="TextBox 11">
+            <a:extLst>
+              <a:ext uri="{FF2B5EF4-FFF2-40B4-BE49-F238E27FC236}">
+                <a16:creationId xmlns:a16="http://schemas.microsoft.com/office/drawing/2014/main" id="{F6965426-731F-6944-5A33-E706046C4CBE}"/>
+              </a:ext>
+            </a:extLst>
+          </p:cNvPr>
+          <p:cNvSpPr txBox="1"/>
+          <p:nvPr/>
+        </p:nvSpPr>
+        <p:spPr>
+          <a:xfrm>
+            <a:off x="9372335" y="5433098"/>
+            <a:ext cx="814339" cy="369332"/>
+          </a:xfrm>
+          <a:prstGeom prst="rect">
+            <a:avLst/>
+          </a:prstGeom>
+          <a:noFill/>
+          <a:ln w="28575">
+            <a:solidFill>
+              <a:srgbClr val="00B050"/>
+            </a:solidFill>
+          </a:ln>
+        </p:spPr>
+        <p:txBody>
+          <a:bodyPr wrap="square" rtlCol="0">
+            <a:spAutoFit/>
+          </a:bodyPr>
+          <a:lstStyle/>
+          <a:p>
+            <a:r>
+              <a:rPr lang="en-US" b="1" dirty="0"/>
+              <a:t>MOVE</a:t>
+            </a:r>
+            <a:endParaRPr lang="en-US" noProof="0" dirty="0"/>
+          </a:p>
+        </p:txBody>
+      </p:sp>
+      <p:sp>
+        <p:nvSpPr>
+          <p:cNvPr id="14" name="TextBox 13">
+            <a:extLst>
+              <a:ext uri="{FF2B5EF4-FFF2-40B4-BE49-F238E27FC236}">
+                <a16:creationId xmlns:a16="http://schemas.microsoft.com/office/drawing/2014/main" id="{A590DD13-D386-B357-3737-419BCBD5208A}"/>
+              </a:ext>
+            </a:extLst>
+          </p:cNvPr>
+          <p:cNvSpPr txBox="1"/>
+          <p:nvPr/>
+        </p:nvSpPr>
+        <p:spPr>
+          <a:xfrm>
+            <a:off x="1132583" y="4440790"/>
+            <a:ext cx="814339" cy="369332"/>
+          </a:xfrm>
+          <a:prstGeom prst="rect">
+            <a:avLst/>
+          </a:prstGeom>
+          <a:noFill/>
+          <a:ln w="28575">
+            <a:solidFill>
+              <a:srgbClr val="00B050"/>
+            </a:solidFill>
+          </a:ln>
+        </p:spPr>
+        <p:txBody>
+          <a:bodyPr wrap="square" rtlCol="0">
+            <a:spAutoFit/>
+          </a:bodyPr>
+          <a:lstStyle/>
+          <a:p>
+            <a:r>
+              <a:rPr lang="en-US" b="1" dirty="0"/>
+              <a:t>MOVE</a:t>
+            </a:r>
+            <a:endParaRPr lang="en-US" noProof="0" dirty="0"/>
+          </a:p>
+        </p:txBody>
+      </p:sp>
+      <p:cxnSp>
+        <p:nvCxnSpPr>
+          <p:cNvPr id="15" name="Straight Connector 14">
+            <a:extLst>
+              <a:ext uri="{FF2B5EF4-FFF2-40B4-BE49-F238E27FC236}">
+                <a16:creationId xmlns:a16="http://schemas.microsoft.com/office/drawing/2014/main" id="{158077CD-70B1-1810-42FD-89DF1B5FDA88}"/>
+              </a:ext>
+            </a:extLst>
+          </p:cNvPr>
+          <p:cNvCxnSpPr>
+            <a:cxnSpLocks/>
+            <a:endCxn id="16" idx="2"/>
+          </p:cNvCxnSpPr>
+          <p:nvPr/>
+        </p:nvCxnSpPr>
+        <p:spPr>
+          <a:xfrm flipH="1" flipV="1">
+            <a:off x="6383030" y="1259805"/>
+            <a:ext cx="231504" cy="245528"/>
+          </a:xfrm>
+          <a:prstGeom prst="line">
+            <a:avLst/>
+          </a:prstGeom>
+          <a:ln w="38100">
+            <a:solidFill>
+              <a:srgbClr val="FFC000"/>
+            </a:solidFill>
+          </a:ln>
+        </p:spPr>
+        <p:style>
+          <a:lnRef idx="2">
+            <a:schemeClr val="accent1"/>
+          </a:lnRef>
+          <a:fillRef idx="0">
+            <a:schemeClr val="accent1"/>
+          </a:fillRef>
+          <a:effectRef idx="1">
+            <a:schemeClr val="accent1"/>
+          </a:effectRef>
+          <a:fontRef idx="minor">
+            <a:schemeClr val="tx1"/>
+          </a:fontRef>
+        </p:style>
+      </p:cxnSp>
+      <p:sp>
+        <p:nvSpPr>
+          <p:cNvPr id="16" name="TextBox 15">
+            <a:extLst>
+              <a:ext uri="{FF2B5EF4-FFF2-40B4-BE49-F238E27FC236}">
+                <a16:creationId xmlns:a16="http://schemas.microsoft.com/office/drawing/2014/main" id="{950FCCCE-64F3-CB47-2F5D-6174628C3B77}"/>
+              </a:ext>
+            </a:extLst>
+          </p:cNvPr>
+          <p:cNvSpPr txBox="1"/>
+          <p:nvPr/>
+        </p:nvSpPr>
+        <p:spPr>
+          <a:xfrm>
+            <a:off x="5263684" y="521141"/>
+            <a:ext cx="2238691" cy="738664"/>
+          </a:xfrm>
+          <a:prstGeom prst="rect">
+            <a:avLst/>
+          </a:prstGeom>
+          <a:noFill/>
+          <a:ln w="28575">
+            <a:solidFill>
+              <a:srgbClr val="FFC000"/>
+            </a:solidFill>
+          </a:ln>
+        </p:spPr>
+        <p:txBody>
+          <a:bodyPr wrap="square" rtlCol="0">
+            <a:spAutoFit/>
+          </a:bodyPr>
+          <a:lstStyle/>
+          <a:p>
+            <a:r>
+              <a:rPr lang="en-US" sz="1400" noProof="0" dirty="0"/>
+              <a:t>Sends the “</a:t>
+            </a:r>
+            <a:r>
+              <a:rPr lang="en-US" sz="1400" b="1" noProof="0" dirty="0"/>
+              <a:t>start</a:t>
+            </a:r>
+            <a:r>
+              <a:rPr lang="en-US" sz="1400" noProof="0" dirty="0"/>
+              <a:t>” signal to the robot</a:t>
+            </a:r>
+            <a:r>
+              <a:rPr lang="en-US" sz="1400" dirty="0"/>
+              <a:t> and also opens the debugging panel</a:t>
+            </a:r>
+            <a:endParaRPr lang="en-US" sz="1400" noProof="0" dirty="0"/>
           </a:p>
         </p:txBody>
       </p:sp>

</xml_diff>